<commit_message>
Redesign slides 4-5 of sales V2 deck: Pareto bar chart and growth story
Slide 4 (customer distribution) was an exact duplicate of slide 3 (same
title, same 9-category pie data). Kept the data unchanged per instructions
and gave it a distinct visual: a ranked horizontal bar chart (gold accent
on the top customer, navy-to-ice-blue gradient for the rest) instead of
the pie3D used on slide 3.

Slide 5 (growth story) had an unstyled default column chart with a stray,
mis-colored "CAGR +5.6%" annotation left over from an earlier draft.
Replaced it with: 2026 highlighted in brand navy vs. muted slate for prior
years, clear value labels, a clean internal chart title, and a redesigned
navy trend line with a gold "+24.5%" badge showing total growth 2022→2026.

Slides 1-3 and their charts are untouched (verified byte-identical diff=0
against the user's edited version).

Co-Authored-By: Claude Sonnet 5 <noreply@anthropic.com>
Claude-Session: https://claude.ai/code/session_01E9QvuhBZminJvrtKVH8YY8
</commit_message>
<xml_diff>
--- a/svetlana/outputs/2026-10-27-מכירות-סטטוס-ותחזית-2026-V2.pptx
+++ b/svetlana/outputs/2026-10-27-מכירות-סטטוס-ותחזית-2026-V2.pptx
@@ -1838,736 +1838,194 @@
   <c:roundedCorners val="0"/>
   <mc:AlternateContent xmlns:mc="http://schemas.openxmlformats.org/markup-compatibility/2006">
     <mc:Choice xmlns:c14="http://schemas.microsoft.com/office/drawing/2007/8/2/chart" Requires="c14">
-      <c14:style val="103"/>
+      <c14:style val="102"/>
     </mc:Choice>
     <mc:Fallback>
-      <c:style val="3"/>
+      <c:style val="2"/>
     </mc:Fallback>
   </mc:AlternateContent>
   <c:chart>
     <c:autoTitleDeleted val="1"/>
-    <c:view3D>
-      <c:rotX val="30"/>
-      <c:rotY val="0"/>
-      <c:depthPercent val="100"/>
-      <c:rAngAx val="0"/>
-    </c:view3D>
-    <c:floor>
-      <c:thickness val="0"/>
-      <c:spPr>
-        <a:noFill/>
-        <a:ln>
-          <a:noFill/>
-        </a:ln>
-        <a:effectLst/>
-        <a:sp3d/>
-      </c:spPr>
-    </c:floor>
-    <c:sideWall>
-      <c:thickness val="0"/>
-      <c:spPr>
-        <a:noFill/>
-        <a:ln>
-          <a:noFill/>
-        </a:ln>
-        <a:effectLst/>
-        <a:sp3d/>
-      </c:spPr>
-    </c:sideWall>
-    <c:backWall>
-      <c:thickness val="0"/>
-      <c:spPr>
-        <a:noFill/>
-        <a:ln>
-          <a:noFill/>
-        </a:ln>
-        <a:effectLst/>
-        <a:sp3d/>
-      </c:spPr>
-    </c:backWall>
     <c:plotArea>
       <c:layout/>
-      <c:pie3DChart>
+      <c:barChart>
+        <c:barDir val="bar"/>
+        <c:grouping val="clustered"/>
         <c:varyColors val="1"/>
         <c:ser>
           <c:idx val="0"/>
           <c:order val="0"/>
+          <c:spPr>
+            <a:solidFill>
+              <a:srgbClr val="002F6C"/>
+            </a:solidFill>
+            <a:ln>
+              <a:noFill/>
+            </a:ln>
+            <a:effectLst/>
+          </c:spPr>
+          <c:invertIfNegative val="0"/>
           <c:dPt>
             <c:idx val="0"/>
+            <c:invertIfNegative val="0"/>
             <c:bubble3D val="0"/>
             <c:spPr>
               <a:solidFill>
-                <a:schemeClr val="accent1">
-                  <a:shade val="44000"/>
-                </a:schemeClr>
+                <a:srgbClr val="E0A62B"/>
               </a:solidFill>
               <a:ln>
                 <a:noFill/>
               </a:ln>
-              <a:effectLst>
-                <a:outerShdw blurRad="88900" sx="102000" sy="102000" algn="ctr" rotWithShape="0">
-                  <a:prstClr val="black">
-                    <a:alpha val="10000"/>
-                  </a:prstClr>
-                </a:outerShdw>
-              </a:effectLst>
-              <a:scene3d>
-                <a:camera prst="orthographicFront"/>
-                <a:lightRig rig="threePt" dir="t"/>
-              </a:scene3d>
-              <a:sp3d>
-                <a:bevelT w="127000" h="127000"/>
-                <a:bevelB w="127000" h="127000"/>
-              </a:sp3d>
+              <a:effectLst/>
             </c:spPr>
-            <c:extLst>
-              <c:ext xmlns:c16="http://schemas.microsoft.com/office/drawing/2014/chart" uri="{C3380CC4-5D6E-409C-BE32-E72D297353CC}">
-                <c16:uniqueId val="{00000001-1499-4A2F-A324-30BA285687A9}"/>
-              </c:ext>
-            </c:extLst>
           </c:dPt>
           <c:dPt>
             <c:idx val="1"/>
+            <c:invertIfNegative val="0"/>
             <c:bubble3D val="0"/>
             <c:spPr>
               <a:solidFill>
-                <a:schemeClr val="accent1">
-                  <a:lumMod val="60000"/>
-                  <a:lumOff val="40000"/>
-                </a:schemeClr>
+                <a:srgbClr val="002F6C"/>
               </a:solidFill>
               <a:ln>
                 <a:noFill/>
               </a:ln>
-              <a:effectLst>
-                <a:outerShdw blurRad="88900" sx="102000" sy="102000" algn="ctr" rotWithShape="0">
-                  <a:prstClr val="black">
-                    <a:alpha val="10000"/>
-                  </a:prstClr>
-                </a:outerShdw>
-              </a:effectLst>
-              <a:scene3d>
-                <a:camera prst="orthographicFront"/>
-                <a:lightRig rig="threePt" dir="t"/>
-              </a:scene3d>
-              <a:sp3d>
-                <a:bevelT w="127000" h="127000"/>
-                <a:bevelB w="127000" h="127000"/>
-              </a:sp3d>
+              <a:effectLst/>
             </c:spPr>
-            <c:extLst>
-              <c:ext xmlns:c16="http://schemas.microsoft.com/office/drawing/2014/chart" uri="{C3380CC4-5D6E-409C-BE32-E72D297353CC}">
-                <c16:uniqueId val="{00000003-1499-4A2F-A324-30BA285687A9}"/>
-              </c:ext>
-            </c:extLst>
           </c:dPt>
           <c:dPt>
             <c:idx val="2"/>
+            <c:invertIfNegative val="0"/>
             <c:bubble3D val="0"/>
             <c:spPr>
               <a:solidFill>
-                <a:schemeClr val="accent1">
-                  <a:lumMod val="40000"/>
-                  <a:lumOff val="60000"/>
-                </a:schemeClr>
+                <a:srgbClr val="1D4881"/>
               </a:solidFill>
               <a:ln>
                 <a:noFill/>
               </a:ln>
-              <a:effectLst>
-                <a:outerShdw blurRad="88900" sx="102000" sy="102000" algn="ctr" rotWithShape="0">
-                  <a:prstClr val="black">
-                    <a:alpha val="10000"/>
-                  </a:prstClr>
-                </a:outerShdw>
-              </a:effectLst>
-              <a:scene3d>
-                <a:camera prst="orthographicFront"/>
-                <a:lightRig rig="threePt" dir="t"/>
-              </a:scene3d>
-              <a:sp3d>
-                <a:bevelT w="127000" h="127000"/>
-                <a:bevelB w="127000" h="127000"/>
-              </a:sp3d>
+              <a:effectLst/>
             </c:spPr>
-            <c:extLst>
-              <c:ext xmlns:c16="http://schemas.microsoft.com/office/drawing/2014/chart" uri="{C3380CC4-5D6E-409C-BE32-E72D297353CC}">
-                <c16:uniqueId val="{00000005-1499-4A2F-A324-30BA285687A9}"/>
-              </c:ext>
-            </c:extLst>
           </c:dPt>
           <c:dPt>
             <c:idx val="3"/>
+            <c:invertIfNegative val="0"/>
             <c:bubble3D val="0"/>
             <c:spPr>
               <a:solidFill>
-                <a:schemeClr val="accent3">
-                  <a:lumMod val="40000"/>
-                  <a:lumOff val="60000"/>
-                </a:schemeClr>
+                <a:srgbClr val="3A6095"/>
               </a:solidFill>
               <a:ln>
                 <a:noFill/>
               </a:ln>
-              <a:effectLst>
-                <a:outerShdw blurRad="88900" sx="102000" sy="102000" algn="ctr" rotWithShape="0">
-                  <a:prstClr val="black">
-                    <a:alpha val="10000"/>
-                  </a:prstClr>
-                </a:outerShdw>
-              </a:effectLst>
-              <a:scene3d>
-                <a:camera prst="orthographicFront"/>
-                <a:lightRig rig="threePt" dir="t"/>
-              </a:scene3d>
-              <a:sp3d>
-                <a:bevelT w="127000" h="127000"/>
-                <a:bevelB w="127000" h="127000"/>
-              </a:sp3d>
+              <a:effectLst/>
             </c:spPr>
-            <c:extLst>
-              <c:ext xmlns:c16="http://schemas.microsoft.com/office/drawing/2014/chart" uri="{C3380CC4-5D6E-409C-BE32-E72D297353CC}">
-                <c16:uniqueId val="{00000007-1499-4A2F-A324-30BA285687A9}"/>
-              </c:ext>
-            </c:extLst>
           </c:dPt>
           <c:dPt>
             <c:idx val="4"/>
+            <c:invertIfNegative val="0"/>
             <c:bubble3D val="0"/>
             <c:spPr>
               <a:solidFill>
-                <a:schemeClr val="accent4">
-                  <a:lumMod val="40000"/>
-                  <a:lumOff val="60000"/>
-                </a:schemeClr>
+                <a:srgbClr val="5779AA"/>
               </a:solidFill>
               <a:ln>
                 <a:noFill/>
               </a:ln>
-              <a:effectLst>
-                <a:outerShdw blurRad="88900" sx="102000" sy="102000" algn="ctr" rotWithShape="0">
-                  <a:prstClr val="black">
-                    <a:alpha val="10000"/>
-                  </a:prstClr>
-                </a:outerShdw>
-              </a:effectLst>
-              <a:scene3d>
-                <a:camera prst="orthographicFront"/>
-                <a:lightRig rig="threePt" dir="t"/>
-              </a:scene3d>
-              <a:sp3d>
-                <a:bevelT w="127000" h="127000"/>
-                <a:bevelB w="127000" h="127000"/>
-              </a:sp3d>
+              <a:effectLst/>
             </c:spPr>
-            <c:extLst>
-              <c:ext xmlns:c16="http://schemas.microsoft.com/office/drawing/2014/chart" uri="{C3380CC4-5D6E-409C-BE32-E72D297353CC}">
-                <c16:uniqueId val="{00000009-1499-4A2F-A324-30BA285687A9}"/>
-              </c:ext>
-            </c:extLst>
           </c:dPt>
           <c:dPt>
             <c:idx val="5"/>
+            <c:invertIfNegative val="0"/>
             <c:bubble3D val="0"/>
             <c:spPr>
               <a:solidFill>
-                <a:schemeClr val="accent4">
-                  <a:lumMod val="20000"/>
-                  <a:lumOff val="80000"/>
-                </a:schemeClr>
+                <a:srgbClr val="7392BE"/>
               </a:solidFill>
               <a:ln>
                 <a:noFill/>
               </a:ln>
-              <a:effectLst>
-                <a:outerShdw blurRad="88900" sx="102000" sy="102000" algn="ctr" rotWithShape="0">
-                  <a:prstClr val="black">
-                    <a:alpha val="10000"/>
-                  </a:prstClr>
-                </a:outerShdw>
-              </a:effectLst>
-              <a:scene3d>
-                <a:camera prst="orthographicFront"/>
-                <a:lightRig rig="threePt" dir="t"/>
-              </a:scene3d>
-              <a:sp3d>
-                <a:bevelT w="127000" h="127000"/>
-                <a:bevelB w="127000" h="127000"/>
-              </a:sp3d>
+              <a:effectLst/>
             </c:spPr>
-            <c:extLst>
-              <c:ext xmlns:c16="http://schemas.microsoft.com/office/drawing/2014/chart" uri="{C3380CC4-5D6E-409C-BE32-E72D297353CC}">
-                <c16:uniqueId val="{0000000B-1499-4A2F-A324-30BA285687A9}"/>
-              </c:ext>
-            </c:extLst>
           </c:dPt>
           <c:dPt>
             <c:idx val="6"/>
+            <c:invertIfNegative val="0"/>
             <c:bubble3D val="0"/>
             <c:spPr>
               <a:solidFill>
-                <a:schemeClr val="tx2"/>
+                <a:srgbClr val="90ABD3"/>
               </a:solidFill>
               <a:ln>
                 <a:noFill/>
               </a:ln>
-              <a:effectLst>
-                <a:outerShdw blurRad="88900" sx="102000" sy="102000" algn="ctr" rotWithShape="0">
-                  <a:prstClr val="black">
-                    <a:alpha val="10000"/>
-                  </a:prstClr>
-                </a:outerShdw>
-              </a:effectLst>
-              <a:scene3d>
-                <a:camera prst="orthographicFront"/>
-                <a:lightRig rig="threePt" dir="t"/>
-              </a:scene3d>
-              <a:sp3d>
-                <a:bevelT w="127000" h="127000"/>
-                <a:bevelB w="127000" h="127000"/>
-              </a:sp3d>
+              <a:effectLst/>
             </c:spPr>
-            <c:extLst>
-              <c:ext xmlns:c16="http://schemas.microsoft.com/office/drawing/2014/chart" uri="{C3380CC4-5D6E-409C-BE32-E72D297353CC}">
-                <c16:uniqueId val="{0000000D-1499-4A2F-A324-30BA285687A9}"/>
-              </c:ext>
-            </c:extLst>
           </c:dPt>
           <c:dPt>
             <c:idx val="7"/>
+            <c:invertIfNegative val="0"/>
             <c:bubble3D val="0"/>
             <c:spPr>
               <a:solidFill>
-                <a:schemeClr val="tx2"/>
+                <a:srgbClr val="ADC3E7"/>
               </a:solidFill>
               <a:ln>
                 <a:noFill/>
               </a:ln>
-              <a:effectLst>
-                <a:outerShdw blurRad="88900" sx="102000" sy="102000" algn="ctr" rotWithShape="0">
-                  <a:prstClr val="black">
-                    <a:alpha val="10000"/>
-                  </a:prstClr>
-                </a:outerShdw>
-              </a:effectLst>
-              <a:scene3d>
-                <a:camera prst="orthographicFront"/>
-                <a:lightRig rig="threePt" dir="t"/>
-              </a:scene3d>
-              <a:sp3d>
-                <a:bevelT w="127000" h="127000"/>
-                <a:bevelB w="127000" h="127000"/>
-              </a:sp3d>
+              <a:effectLst/>
             </c:spPr>
-            <c:extLst>
-              <c:ext xmlns:c16="http://schemas.microsoft.com/office/drawing/2014/chart" uri="{C3380CC4-5D6E-409C-BE32-E72D297353CC}">
-                <c16:uniqueId val="{0000000F-1499-4A2F-A324-30BA285687A9}"/>
-              </c:ext>
-            </c:extLst>
           </c:dPt>
           <c:dPt>
             <c:idx val="8"/>
+            <c:invertIfNegative val="0"/>
             <c:bubble3D val="0"/>
             <c:spPr>
               <a:solidFill>
-                <a:schemeClr val="tx2"/>
+                <a:srgbClr val="CADCFC"/>
               </a:solidFill>
               <a:ln>
                 <a:noFill/>
               </a:ln>
-              <a:effectLst>
-                <a:outerShdw blurRad="88900" sx="102000" sy="102000" algn="ctr" rotWithShape="0">
-                  <a:prstClr val="black">
-                    <a:alpha val="10000"/>
-                  </a:prstClr>
-                </a:outerShdw>
-              </a:effectLst>
-              <a:scene3d>
-                <a:camera prst="orthographicFront"/>
-                <a:lightRig rig="threePt" dir="t"/>
-              </a:scene3d>
-              <a:sp3d>
-                <a:bevelT w="127000" h="127000"/>
-                <a:bevelB w="127000" h="127000"/>
-              </a:sp3d>
+              <a:effectLst/>
             </c:spPr>
-            <c:extLst>
-              <c:ext xmlns:c16="http://schemas.microsoft.com/office/drawing/2014/chart" uri="{C3380CC4-5D6E-409C-BE32-E72D297353CC}">
-                <c16:uniqueId val="{00000011-1499-4A2F-A324-30BA285687A9}"/>
-              </c:ext>
-            </c:extLst>
           </c:dPt>
           <c:dLbls>
-            <c:dLbl>
-              <c:idx val="0"/>
-              <c:layout>
-                <c:manualLayout>
-                  <c:x val="-0.14544825426762334"/>
-                  <c:y val="9.0092494641943494E-2"/>
-                </c:manualLayout>
-              </c:layout>
-              <c:numFmt formatCode="0%" sourceLinked="0"/>
-              <c:spPr>
+            <c:numFmt formatCode="0%" sourceLinked="0"/>
+            <c:spPr>
+              <a:noFill/>
+              <a:ln>
                 <a:noFill/>
-                <a:ln>
-                  <a:noFill/>
-                </a:ln>
-                <a:effectLst/>
-              </c:spPr>
-              <c:txPr>
-                <a:bodyPr rot="0" spcFirstLastPara="1" vertOverflow="ellipsis" vert="horz" wrap="square" lIns="38100" tIns="19050" rIns="38100" bIns="19050" anchor="ctr" anchorCtr="1">
-                  <a:spAutoFit/>
-                </a:bodyPr>
-                <a:lstStyle/>
-                <a:p>
-                  <a:pPr>
-                    <a:defRPr sz="1330" b="1" i="0" u="none" strike="noStrike" kern="1200" spc="0" baseline="0">
-                      <a:solidFill>
-                        <a:schemeClr val="bg1"/>
-                      </a:solidFill>
-                      <a:latin typeface="+mn-lt"/>
-                      <a:ea typeface="+mn-ea"/>
-                      <a:cs typeface="+mn-cs"/>
-                    </a:defRPr>
-                  </a:pPr>
-                  <a:endParaRPr lang="he-IL"/>
-                </a:p>
-              </c:txPr>
-              <c:dLblPos val="bestFit"/>
-              <c:showLegendKey val="0"/>
-              <c:showVal val="0"/>
-              <c:showCatName val="1"/>
-              <c:showSerName val="0"/>
-              <c:showPercent val="1"/>
-              <c:showBubbleSize val="0"/>
-              <c:separator>
-</c:separator>
-              <c:extLst>
-                <c:ext xmlns:c15="http://schemas.microsoft.com/office/drawing/2012/chart" uri="{CE6537A1-D6FC-4f65-9D91-7224C49458BB}"/>
-                <c:ext xmlns:c16="http://schemas.microsoft.com/office/drawing/2014/chart" uri="{C3380CC4-5D6E-409C-BE32-E72D297353CC}">
-                  <c16:uniqueId val="{00000001-1499-4A2F-A324-30BA285687A9}"/>
-                </c:ext>
-              </c:extLst>
-            </c:dLbl>
-            <c:dLbl>
-              <c:idx val="1"/>
-              <c:layout>
-                <c:manualLayout>
-                  <c:x val="-0.17175260394774194"/>
-                  <c:y val="-0.25619823168617623"/>
-                </c:manualLayout>
-              </c:layout>
-              <c:numFmt formatCode="0%" sourceLinked="0"/>
-              <c:spPr>
-                <a:noFill/>
-                <a:ln>
-                  <a:noFill/>
-                </a:ln>
-                <a:effectLst/>
-              </c:spPr>
-              <c:txPr>
-                <a:bodyPr rot="0" spcFirstLastPara="1" vertOverflow="ellipsis" vert="horz" wrap="square" lIns="38100" tIns="19050" rIns="38100" bIns="19050" anchor="ctr" anchorCtr="0">
-                  <a:noAutofit/>
-                </a:bodyPr>
-                <a:lstStyle/>
-                <a:p>
-                  <a:pPr algn="ctr">
-                    <a:defRPr sz="1330" b="1" i="0" u="none" strike="noStrike" kern="1200" spc="0" baseline="0">
-                      <a:solidFill>
-                        <a:schemeClr val="bg1"/>
-                      </a:solidFill>
-                      <a:latin typeface="+mn-lt"/>
-                      <a:ea typeface="+mn-ea"/>
-                      <a:cs typeface="+mn-cs"/>
-                    </a:defRPr>
-                  </a:pPr>
-                  <a:endParaRPr lang="he-IL"/>
-                </a:p>
-              </c:txPr>
-              <c:dLblPos val="bestFit"/>
-              <c:showLegendKey val="0"/>
-              <c:showVal val="0"/>
-              <c:showCatName val="1"/>
-              <c:showSerName val="0"/>
-              <c:showPercent val="1"/>
-              <c:showBubbleSize val="0"/>
-              <c:separator>
-</c:separator>
-              <c:extLst>
-                <c:ext xmlns:c15="http://schemas.microsoft.com/office/drawing/2012/chart" uri="{CE6537A1-D6FC-4f65-9D91-7224C49458BB}">
-                  <c15:layout>
-                    <c:manualLayout>
-                      <c:w val="7.8317634717516293E-2"/>
-                      <c:h val="0.12835238764929183"/>
-                    </c:manualLayout>
-                  </c15:layout>
-                </c:ext>
-                <c:ext xmlns:c16="http://schemas.microsoft.com/office/drawing/2014/chart" uri="{C3380CC4-5D6E-409C-BE32-E72D297353CC}">
-                  <c16:uniqueId val="{00000003-1499-4A2F-A324-30BA285687A9}"/>
-                </c:ext>
-              </c:extLst>
-            </c:dLbl>
-            <c:dLbl>
-              <c:idx val="2"/>
-              <c:layout>
-                <c:manualLayout>
-                  <c:x val="0.11140717348158383"/>
-                  <c:y val="-0.29279772571893725"/>
-                </c:manualLayout>
-              </c:layout>
-              <c:numFmt formatCode="0%" sourceLinked="0"/>
-              <c:spPr>
-                <a:noFill/>
-                <a:ln>
-                  <a:noFill/>
-                </a:ln>
-                <a:effectLst/>
-              </c:spPr>
-              <c:txPr>
-                <a:bodyPr rot="0" spcFirstLastPara="1" vertOverflow="ellipsis" vert="horz" wrap="square" lIns="38100" tIns="19050" rIns="38100" bIns="19050" anchor="ctr" anchorCtr="1">
-                  <a:spAutoFit/>
-                </a:bodyPr>
-                <a:lstStyle/>
-                <a:p>
-                  <a:pPr>
-                    <a:defRPr sz="1330" b="1" i="0" u="none" strike="noStrike" kern="1200" spc="0" baseline="0">
-                      <a:solidFill>
-                        <a:schemeClr val="accent1">
-                          <a:shade val="72000"/>
-                        </a:schemeClr>
-                      </a:solidFill>
-                      <a:latin typeface="+mn-lt"/>
-                      <a:ea typeface="+mn-ea"/>
-                      <a:cs typeface="+mn-cs"/>
-                    </a:defRPr>
-                  </a:pPr>
-                  <a:endParaRPr lang="he-IL"/>
-                </a:p>
-              </c:txPr>
-              <c:dLblPos val="bestFit"/>
-              <c:showLegendKey val="0"/>
-              <c:showVal val="0"/>
-              <c:showCatName val="1"/>
-              <c:showSerName val="0"/>
-              <c:showPercent val="1"/>
-              <c:showBubbleSize val="0"/>
-              <c:separator>
-</c:separator>
-              <c:extLst>
-                <c:ext xmlns:c15="http://schemas.microsoft.com/office/drawing/2012/chart" uri="{CE6537A1-D6FC-4f65-9D91-7224C49458BB}"/>
-                <c:ext xmlns:c16="http://schemas.microsoft.com/office/drawing/2014/chart" uri="{C3380CC4-5D6E-409C-BE32-E72D297353CC}">
-                  <c16:uniqueId val="{00000005-1499-4A2F-A324-30BA285687A9}"/>
-                </c:ext>
-              </c:extLst>
-            </c:dLbl>
-            <c:dLbl>
-              <c:idx val="3"/>
-              <c:layout>
-                <c:manualLayout>
-                  <c:x val="0.1377116449980689"/>
-                  <c:y val="-0.166106402090551"/>
-                </c:manualLayout>
-              </c:layout>
-              <c:numFmt formatCode="0%" sourceLinked="0"/>
-              <c:spPr>
-                <a:noFill/>
-                <a:ln>
-                  <a:noFill/>
-                </a:ln>
-                <a:effectLst/>
-              </c:spPr>
-              <c:txPr>
-                <a:bodyPr rot="0" spcFirstLastPara="1" vertOverflow="ellipsis" vert="horz" wrap="square" lIns="38100" tIns="19050" rIns="38100" bIns="19050" anchor="ctr" anchorCtr="1">
-                  <a:spAutoFit/>
-                </a:bodyPr>
-                <a:lstStyle/>
-                <a:p>
-                  <a:pPr>
-                    <a:defRPr sz="1330" b="1" i="0" u="none" strike="noStrike" kern="1200" spc="0" baseline="0">
-                      <a:solidFill>
-                        <a:schemeClr val="tx2">
-                          <a:lumMod val="25000"/>
-                        </a:schemeClr>
-                      </a:solidFill>
-                      <a:latin typeface="+mn-lt"/>
-                      <a:ea typeface="+mn-ea"/>
-                      <a:cs typeface="+mn-cs"/>
-                    </a:defRPr>
-                  </a:pPr>
-                  <a:endParaRPr lang="he-IL"/>
-                </a:p>
-              </c:txPr>
-              <c:dLblPos val="bestFit"/>
-              <c:showLegendKey val="0"/>
-              <c:showVal val="0"/>
-              <c:showCatName val="1"/>
-              <c:showSerName val="0"/>
-              <c:showPercent val="1"/>
-              <c:showBubbleSize val="0"/>
-              <c:separator>
-</c:separator>
-              <c:extLst>
-                <c:ext xmlns:c15="http://schemas.microsoft.com/office/drawing/2012/chart" uri="{CE6537A1-D6FC-4f65-9D91-7224C49458BB}"/>
-                <c:ext xmlns:c16="http://schemas.microsoft.com/office/drawing/2014/chart" uri="{C3380CC4-5D6E-409C-BE32-E72D297353CC}">
-                  <c16:uniqueId val="{00000007-1499-4A2F-A324-30BA285687A9}"/>
-                </c:ext>
-              </c:extLst>
-            </c:dLbl>
-            <c:dLbl>
-              <c:idx val="4"/>
-              <c:layout>
-                <c:manualLayout>
-                  <c:x val="0.14003262777893521"/>
-                  <c:y val="3.6599937396973231E-2"/>
-                </c:manualLayout>
-              </c:layout>
-              <c:numFmt formatCode="0%" sourceLinked="0"/>
-              <c:spPr>
-                <a:noFill/>
-                <a:ln>
-                  <a:noFill/>
-                </a:ln>
-                <a:effectLst/>
-              </c:spPr>
-              <c:txPr>
-                <a:bodyPr rot="0" spcFirstLastPara="1" vertOverflow="ellipsis" vert="horz" wrap="square" lIns="38100" tIns="19050" rIns="38100" bIns="19050" anchor="ctr" anchorCtr="1">
-                  <a:spAutoFit/>
-                </a:bodyPr>
-                <a:lstStyle/>
-                <a:p>
-                  <a:pPr>
-                    <a:defRPr sz="1200" b="1" i="0" u="none" strike="noStrike" kern="1200" spc="0" baseline="0">
-                      <a:solidFill>
-                        <a:schemeClr val="accent1"/>
-                      </a:solidFill>
-                      <a:latin typeface="+mn-lt"/>
-                      <a:ea typeface="+mn-ea"/>
-                      <a:cs typeface="+mn-cs"/>
-                    </a:defRPr>
-                  </a:pPr>
-                  <a:endParaRPr lang="he-IL"/>
-                </a:p>
-              </c:txPr>
-              <c:dLblPos val="bestFit"/>
-              <c:showLegendKey val="0"/>
-              <c:showVal val="0"/>
-              <c:showCatName val="1"/>
-              <c:showSerName val="0"/>
-              <c:showPercent val="1"/>
-              <c:showBubbleSize val="0"/>
-              <c:separator>
-</c:separator>
-              <c:extLst>
-                <c:ext xmlns:c15="http://schemas.microsoft.com/office/drawing/2012/chart" uri="{CE6537A1-D6FC-4f65-9D91-7224C49458BB}">
-                  <c15:layout>
-                    <c:manualLayout>
-                      <c:w val="0.11122149485911452"/>
-                      <c:h val="9.4568034681722118E-2"/>
-                    </c:manualLayout>
-                  </c15:layout>
-                </c:ext>
-                <c:ext xmlns:c16="http://schemas.microsoft.com/office/drawing/2014/chart" uri="{C3380CC4-5D6E-409C-BE32-E72D297353CC}">
-                  <c16:uniqueId val="{00000009-1499-4A2F-A324-30BA285687A9}"/>
-                </c:ext>
-              </c:extLst>
-            </c:dLbl>
-            <c:dLbl>
-              <c:idx val="5"/>
-              <c:layout>
-                <c:manualLayout>
-                  <c:x val="0.10212324235811851"/>
-                  <c:y val="7.6014794177031789E-2"/>
-                </c:manualLayout>
-              </c:layout>
-              <c:numFmt formatCode="0%" sourceLinked="0"/>
-              <c:spPr>
-                <a:noFill/>
-                <a:ln>
-                  <a:noFill/>
-                </a:ln>
-                <a:effectLst/>
-              </c:spPr>
-              <c:txPr>
-                <a:bodyPr rot="0" spcFirstLastPara="1" vertOverflow="ellipsis" vert="horz" wrap="square" lIns="38100" tIns="19050" rIns="38100" bIns="19050" anchor="ctr" anchorCtr="1">
-                  <a:spAutoFit/>
-                </a:bodyPr>
-                <a:lstStyle/>
-                <a:p>
-                  <a:pPr>
-                    <a:defRPr sz="1000" b="1" i="0" u="none" strike="noStrike" kern="1200" spc="0" baseline="0">
-                      <a:solidFill>
-                        <a:schemeClr val="accent1">
-                          <a:tint val="86000"/>
-                        </a:schemeClr>
-                      </a:solidFill>
-                      <a:latin typeface="+mn-lt"/>
-                      <a:ea typeface="+mn-ea"/>
-                      <a:cs typeface="+mn-cs"/>
-                    </a:defRPr>
-                  </a:pPr>
-                  <a:endParaRPr lang="he-IL"/>
-                </a:p>
-              </c:txPr>
-              <c:dLblPos val="bestFit"/>
-              <c:showLegendKey val="0"/>
-              <c:showVal val="0"/>
-              <c:showCatName val="1"/>
-              <c:showSerName val="0"/>
-              <c:showPercent val="1"/>
-              <c:showBubbleSize val="0"/>
-              <c:separator>
-</c:separator>
-              <c:extLst>
-                <c:ext xmlns:c15="http://schemas.microsoft.com/office/drawing/2012/chart" uri="{CE6537A1-D6FC-4f65-9D91-7224C49458BB}"/>
-                <c:ext xmlns:c16="http://schemas.microsoft.com/office/drawing/2014/chart" uri="{C3380CC4-5D6E-409C-BE32-E72D297353CC}">
-                  <c16:uniqueId val="{0000000B-1499-4A2F-A324-30BA285687A9}"/>
-                </c:ext>
-              </c:extLst>
-            </c:dLbl>
-            <c:dLbl>
-              <c:idx val="6"/>
-              <c:delete val="1"/>
-              <c:extLst>
-                <c:ext xmlns:c15="http://schemas.microsoft.com/office/drawing/2012/chart" uri="{CE6537A1-D6FC-4f65-9D91-7224C49458BB}"/>
-                <c:ext xmlns:c16="http://schemas.microsoft.com/office/drawing/2014/chart" uri="{C3380CC4-5D6E-409C-BE32-E72D297353CC}">
-                  <c16:uniqueId val="{0000000D-1499-4A2F-A324-30BA285687A9}"/>
-                </c:ext>
-              </c:extLst>
-            </c:dLbl>
-            <c:dLbl>
-              <c:idx val="7"/>
-              <c:delete val="1"/>
-              <c:extLst>
-                <c:ext xmlns:c15="http://schemas.microsoft.com/office/drawing/2012/chart" uri="{CE6537A1-D6FC-4f65-9D91-7224C49458BB}"/>
-                <c:ext xmlns:c16="http://schemas.microsoft.com/office/drawing/2014/chart" uri="{C3380CC4-5D6E-409C-BE32-E72D297353CC}">
-                  <c16:uniqueId val="{0000000F-1499-4A2F-A324-30BA285687A9}"/>
-                </c:ext>
-              </c:extLst>
-            </c:dLbl>
-            <c:dLbl>
-              <c:idx val="8"/>
-              <c:delete val="1"/>
-              <c:extLst>
-                <c:ext xmlns:c15="http://schemas.microsoft.com/office/drawing/2012/chart" uri="{CE6537A1-D6FC-4f65-9D91-7224C49458BB}"/>
-                <c:ext xmlns:c16="http://schemas.microsoft.com/office/drawing/2014/chart" uri="{C3380CC4-5D6E-409C-BE32-E72D297353CC}">
-                  <c16:uniqueId val="{00000011-1499-4A2F-A324-30BA285687A9}"/>
-                </c:ext>
-              </c:extLst>
-            </c:dLbl>
-            <c:numFmt formatCode="0%" sourceLinked="0"/>
+              </a:ln>
+              <a:effectLst/>
+            </c:spPr>
+            <c:txPr>
+              <a:bodyPr rot="0" spcFirstLastPara="1" vertOverflow="ellipsis" vert="horz" wrap="square" lIns="38100" tIns="19050" rIns="38100" bIns="19050" anchor="ctr" anchorCtr="1">
+                <a:spAutoFit/>
+              </a:bodyPr>
+              <a:lstStyle/>
+              <a:p>
+                <a:pPr>
+                  <a:defRPr sz="1100" b="1" i="0" u="none" strike="noStrike" kern="1200" baseline="0">
+                    <a:solidFill>
+                      <a:srgbClr val="002F6C"/>
+                    </a:solidFill>
+                    <a:latin typeface="+mn-lt"/>
+                    <a:ea typeface="+mn-ea"/>
+                    <a:cs typeface="+mn-cs"/>
+                  </a:defRPr>
+                </a:pPr>
+                <a:endParaRPr lang="he-IL"/>
+              </a:p>
+            </c:txPr>
             <c:dLblPos val="outEnd"/>
             <c:showLegendKey val="0"/>
-            <c:showVal val="0"/>
-            <c:showCatName val="1"/>
+            <c:showVal val="1"/>
+            <c:showCatName val="0"/>
             <c:showSerName val="0"/>
-            <c:showPercent val="1"/>
+            <c:showPercent val="0"/>
             <c:showBubbleSize val="0"/>
-            <c:separator>
-</c:separator>
-            <c:showLeaderLines val="0"/>
-            <c:extLst>
-              <c:ext xmlns:c15="http://schemas.microsoft.com/office/drawing/2012/chart" uri="{CE6537A1-D6FC-4f65-9D91-7224C49458BB}"/>
-            </c:extLst>
           </c:dLbls>
           <c:cat>
             <c:strRef>
@@ -2642,21 +2100,89 @@
           </c:val>
           <c:extLst>
             <c:ext xmlns:c16="http://schemas.microsoft.com/office/drawing/2014/chart" uri="{C3380CC4-5D6E-409C-BE32-E72D297353CC}">
-              <c16:uniqueId val="{00000000-1031-448D-A72E-6B1B4152A565}"/>
+              <c16:uniqueId val="{00000001-AAAA-4A2F-A324-30BA285687A9}"/>
             </c:ext>
           </c:extLst>
         </c:ser>
         <c:dLbls>
-          <c:dLblPos val="outEnd"/>
           <c:showLegendKey val="0"/>
           <c:showVal val="0"/>
-          <c:showCatName val="1"/>
+          <c:showCatName val="0"/>
           <c:showSerName val="0"/>
           <c:showPercent val="0"/>
           <c:showBubbleSize val="0"/>
-          <c:showLeaderLines val="0"/>
         </c:dLbls>
-      </c:pie3DChart>
+        <c:gapWidth val="45"/>
+        <c:axId val="411000001"/>
+        <c:axId val="411000002"/>
+      </c:barChart>
+      <c:catAx>
+        <c:axId val="411000001"/>
+        <c:scaling>
+          <c:orientation val="maxMin"/>
+        </c:scaling>
+        <c:delete val="0"/>
+        <c:axPos val="r"/>
+        <c:numFmt formatCode="General" sourceLinked="1"/>
+        <c:majorTickMark val="none"/>
+        <c:minorTickMark val="none"/>
+        <c:tickLblPos val="nextTo"/>
+        <c:spPr>
+          <a:noFill/>
+          <a:ln w="9525" cap="flat" cmpd="sng" algn="ctr">
+            <a:noFill/>
+            <a:round/>
+          </a:ln>
+          <a:effectLst/>
+        </c:spPr>
+        <c:txPr>
+          <a:bodyPr rot="0" spcFirstLastPara="1" vertOverflow="ellipsis" vert="horz" wrap="square" anchor="ctr" anchorCtr="1"/>
+          <a:lstStyle/>
+          <a:p>
+            <a:pPr>
+              <a:defRPr sz="1200" b="1" i="0" u="none" strike="noStrike" kern="1200" baseline="0">
+                <a:solidFill>
+                  <a:srgbClr val="002F6C"/>
+                </a:solidFill>
+                <a:latin typeface="+mn-lt"/>
+                <a:ea typeface="+mn-ea"/>
+                <a:cs typeface="+mn-cs"/>
+              </a:defRPr>
+            </a:pPr>
+            <a:endParaRPr lang="he-IL"/>
+          </a:p>
+        </c:txPr>
+        <c:crossAx val="411000002"/>
+        <c:crosses val="autoZero"/>
+        <c:auto val="1"/>
+        <c:lblAlgn val="ctr"/>
+        <c:lblOffset val="100"/>
+        <c:noMultiLvlLbl val="0"/>
+      </c:catAx>
+      <c:valAx>
+        <c:axId val="411000002"/>
+        <c:scaling>
+          <c:orientation val="maxMin"/>
+          <c:max val="0.34"/>
+          <c:min val="0"/>
+        </c:scaling>
+        <c:delete val="1"/>
+        <c:axPos val="b"/>
+        <c:numFmt formatCode="0%" sourceLinked="0"/>
+        <c:majorTickMark val="none"/>
+        <c:minorTickMark val="none"/>
+        <c:tickLblPos val="none"/>
+        <c:spPr>
+          <a:noFill/>
+          <a:ln>
+            <a:noFill/>
+          </a:ln>
+          <a:effectLst/>
+        </c:spPr>
+        <c:crossAx val="411000001"/>
+        <c:crosses val="autoZero"/>
+        <c:crossBetween val="between"/>
+      </c:valAx>
       <c:spPr>
         <a:noFill/>
         <a:ln>
@@ -2668,13 +2194,6 @@
     <c:plotVisOnly val="1"/>
     <c:dispBlanksAs val="gap"/>
     <c:showDLblsOverMax val="0"/>
-    <c:extLst>
-      <c:ext xmlns:c16r3="http://schemas.microsoft.com/office/drawing/2017/03/chart" uri="{56B9EC1D-385E-4148-901F-78D8002777C0}">
-        <c16r3:dataDisplayOptions16>
-          <c16r3:dispNaAsBlank val="1"/>
-        </c16r3:dataDisplayOptions16>
-      </c:ext>
-    </c:extLst>
   </c:chart>
   <c:spPr>
     <a:noFill/>
@@ -2713,19 +2232,65 @@
     </mc:Fallback>
   </mc:AlternateContent>
   <c:chart>
-    <c:autoTitleDeleted val="1"/>
+    <c:title>
+      <c:layout>
+        <c:manualLayout>
+          <c:xMode val="edge"/>
+          <c:yMode val="edge"/>
+          <c:x val="0.70"/>
+          <c:y val="0.0"/>
+        </c:manualLayout>
+      </c:layout>
+      <c:tx>
+        <c:rich>
+          <a:bodyPr rot="0" spcFirstLastPara="1" vertOverflow="ellipsis" vert="horz" wrap="square" anchor="t" anchorCtr="0"/>
+          <a:lstStyle/>
+          <a:p>
+            <a:pPr algn="r">
+              <a:defRPr sz="1100" b="0" i="0" u="none" strike="noStrike" kern="1200" baseline="0">
+                <a:solidFill>
+                  <a:srgbClr val="5B6B82"/>
+                </a:solidFill>
+                <a:latin typeface="+mn-lt"/>
+                <a:ea typeface="+mn-ea"/>
+                <a:cs typeface="+mn-cs"/>
+              </a:defRPr>
+            </a:pPr>
+            <a:r>
+              <a:rPr lang="he-IL" sz="1100" b="0" dirty="0">
+                <a:solidFill>
+                  <a:srgbClr val="5B6B82"/>
+                </a:solidFill>
+                <a:latin typeface="+mn-lt"/>
+                <a:cs typeface="+mn-lt"/>
+              </a:rPr>
+              <a:t>מכירות שנתיות (₪ מיליון)</a:t>
+            </a:r>
+          </a:p>
+        </c:rich>
+      </c:tx>
+      <c:overlay val="0"/>
+      <c:spPr>
+        <a:noFill/>
+        <a:ln>
+          <a:noFill/>
+        </a:ln>
+        <a:effectLst/>
+      </c:spPr>
+    </c:title>
+    <c:autoTitleDeleted val="0"/>
     <c:plotArea>
       <c:layout/>
       <c:barChart>
         <c:barDir val="col"/>
         <c:grouping val="clustered"/>
-        <c:varyColors val="0"/>
+        <c:varyColors val="1"/>
         <c:ser>
           <c:idx val="0"/>
           <c:order val="0"/>
           <c:spPr>
             <a:solidFill>
-              <a:schemeClr val="accent1"/>
+              <a:srgbClr val="002F6C"/>
             </a:solidFill>
             <a:ln>
               <a:noFill/>
@@ -2733,7 +2298,252 @@
             <a:effectLst/>
           </c:spPr>
           <c:invertIfNegative val="0"/>
+          <c:dPt>
+            <c:idx val="0"/>
+            <c:invertIfNegative val="0"/>
+            <c:bubble3D val="0"/>
+            <c:spPr>
+              <a:solidFill>
+                <a:srgbClr val="5B6B82"/>
+              </a:solidFill>
+              <a:ln>
+                <a:noFill/>
+              </a:ln>
+              <a:effectLst/>
+            </c:spPr>
+          </c:dPt>
+          <c:dPt>
+            <c:idx val="1"/>
+            <c:invertIfNegative val="0"/>
+            <c:bubble3D val="0"/>
+            <c:spPr>
+              <a:solidFill>
+                <a:srgbClr val="5B6B82"/>
+              </a:solidFill>
+              <a:ln>
+                <a:noFill/>
+              </a:ln>
+              <a:effectLst/>
+            </c:spPr>
+          </c:dPt>
+          <c:dPt>
+            <c:idx val="2"/>
+            <c:invertIfNegative val="0"/>
+            <c:bubble3D val="0"/>
+            <c:spPr>
+              <a:solidFill>
+                <a:srgbClr val="5B6B82"/>
+              </a:solidFill>
+              <a:ln>
+                <a:noFill/>
+              </a:ln>
+              <a:effectLst/>
+            </c:spPr>
+          </c:dPt>
+          <c:dPt>
+            <c:idx val="3"/>
+            <c:invertIfNegative val="0"/>
+            <c:bubble3D val="0"/>
+            <c:spPr>
+              <a:solidFill>
+                <a:srgbClr val="5B6B82"/>
+              </a:solidFill>
+              <a:ln>
+                <a:noFill/>
+              </a:ln>
+              <a:effectLst/>
+            </c:spPr>
+          </c:dPt>
+          <c:dPt>
+            <c:idx val="4"/>
+            <c:invertIfNegative val="0"/>
+            <c:bubble3D val="0"/>
+            <c:spPr>
+              <a:solidFill>
+                <a:srgbClr val="002F6C"/>
+              </a:solidFill>
+              <a:ln>
+                <a:noFill/>
+              </a:ln>
+              <a:effectLst/>
+            </c:spPr>
+          </c:dPt>
           <c:dLbls>
+            <c:dLbl>
+              <c:idx val="0"/>
+              <c:spPr>
+                <a:noFill/>
+                <a:ln>
+                  <a:noFill/>
+                </a:ln>
+              </c:spPr>
+              <c:txPr>
+                <a:bodyPr rot="0" spcFirstLastPara="1" vertOverflow="ellipsis" vert="horz" wrap="square" lIns="38100" tIns="19050" rIns="38100" bIns="19050" anchor="ctr" anchorCtr="1">
+                  <a:spAutoFit/>
+                </a:bodyPr>
+                <a:lstStyle/>
+                <a:p>
+                  <a:pPr>
+                    <a:defRPr sz="1200" b="1" i="0" u="none" strike="noStrike" kern="1200" baseline="0">
+                      <a:solidFill>
+                        <a:srgbClr val="5B6B82"/>
+                      </a:solidFill>
+                      <a:latin typeface="+mn-lt"/>
+                      <a:ea typeface="+mn-ea"/>
+                      <a:cs typeface="+mn-cs"/>
+                    </a:defRPr>
+                  </a:pPr>
+                  <a:endParaRPr lang="he-IL"/>
+                </a:p>
+              </c:txPr>
+              <c:dLblPos val="outEnd"/>
+              <c:showLegendKey val="0"/>
+              <c:showVal val="1"/>
+              <c:showCatName val="0"/>
+              <c:showSerName val="0"/>
+              <c:showPercent val="0"/>
+              <c:showBubbleSize val="0"/>
+            </c:dLbl>
+            <c:dLbl>
+              <c:idx val="1"/>
+              <c:spPr>
+                <a:noFill/>
+                <a:ln>
+                  <a:noFill/>
+                </a:ln>
+              </c:spPr>
+              <c:txPr>
+                <a:bodyPr rot="0" spcFirstLastPara="1" vertOverflow="ellipsis" vert="horz" wrap="square" lIns="38100" tIns="19050" rIns="38100" bIns="19050" anchor="ctr" anchorCtr="1">
+                  <a:spAutoFit/>
+                </a:bodyPr>
+                <a:lstStyle/>
+                <a:p>
+                  <a:pPr>
+                    <a:defRPr sz="1200" b="1" i="0" u="none" strike="noStrike" kern="1200" baseline="0">
+                      <a:solidFill>
+                        <a:srgbClr val="5B6B82"/>
+                      </a:solidFill>
+                      <a:latin typeface="+mn-lt"/>
+                      <a:ea typeface="+mn-ea"/>
+                      <a:cs typeface="+mn-cs"/>
+                    </a:defRPr>
+                  </a:pPr>
+                  <a:endParaRPr lang="he-IL"/>
+                </a:p>
+              </c:txPr>
+              <c:dLblPos val="outEnd"/>
+              <c:showLegendKey val="0"/>
+              <c:showVal val="1"/>
+              <c:showCatName val="0"/>
+              <c:showSerName val="0"/>
+              <c:showPercent val="0"/>
+              <c:showBubbleSize val="0"/>
+            </c:dLbl>
+            <c:dLbl>
+              <c:idx val="2"/>
+              <c:spPr>
+                <a:noFill/>
+                <a:ln>
+                  <a:noFill/>
+                </a:ln>
+              </c:spPr>
+              <c:txPr>
+                <a:bodyPr rot="0" spcFirstLastPara="1" vertOverflow="ellipsis" vert="horz" wrap="square" lIns="38100" tIns="19050" rIns="38100" bIns="19050" anchor="ctr" anchorCtr="1">
+                  <a:spAutoFit/>
+                </a:bodyPr>
+                <a:lstStyle/>
+                <a:p>
+                  <a:pPr>
+                    <a:defRPr sz="1200" b="1" i="0" u="none" strike="noStrike" kern="1200" baseline="0">
+                      <a:solidFill>
+                        <a:srgbClr val="5B6B82"/>
+                      </a:solidFill>
+                      <a:latin typeface="+mn-lt"/>
+                      <a:ea typeface="+mn-ea"/>
+                      <a:cs typeface="+mn-cs"/>
+                    </a:defRPr>
+                  </a:pPr>
+                  <a:endParaRPr lang="he-IL"/>
+                </a:p>
+              </c:txPr>
+              <c:dLblPos val="outEnd"/>
+              <c:showLegendKey val="0"/>
+              <c:showVal val="1"/>
+              <c:showCatName val="0"/>
+              <c:showSerName val="0"/>
+              <c:showPercent val="0"/>
+              <c:showBubbleSize val="0"/>
+            </c:dLbl>
+            <c:dLbl>
+              <c:idx val="3"/>
+              <c:spPr>
+                <a:noFill/>
+                <a:ln>
+                  <a:noFill/>
+                </a:ln>
+              </c:spPr>
+              <c:txPr>
+                <a:bodyPr rot="0" spcFirstLastPara="1" vertOverflow="ellipsis" vert="horz" wrap="square" lIns="38100" tIns="19050" rIns="38100" bIns="19050" anchor="ctr" anchorCtr="1">
+                  <a:spAutoFit/>
+                </a:bodyPr>
+                <a:lstStyle/>
+                <a:p>
+                  <a:pPr>
+                    <a:defRPr sz="1200" b="1" i="0" u="none" strike="noStrike" kern="1200" baseline="0">
+                      <a:solidFill>
+                        <a:srgbClr val="5B6B82"/>
+                      </a:solidFill>
+                      <a:latin typeface="+mn-lt"/>
+                      <a:ea typeface="+mn-ea"/>
+                      <a:cs typeface="+mn-cs"/>
+                    </a:defRPr>
+                  </a:pPr>
+                  <a:endParaRPr lang="he-IL"/>
+                </a:p>
+              </c:txPr>
+              <c:dLblPos val="outEnd"/>
+              <c:showLegendKey val="0"/>
+              <c:showVal val="1"/>
+              <c:showCatName val="0"/>
+              <c:showSerName val="0"/>
+              <c:showPercent val="0"/>
+              <c:showBubbleSize val="0"/>
+            </c:dLbl>
+            <c:dLbl>
+              <c:idx val="4"/>
+              <c:spPr>
+                <a:noFill/>
+                <a:ln>
+                  <a:noFill/>
+                </a:ln>
+              </c:spPr>
+              <c:txPr>
+                <a:bodyPr rot="0" spcFirstLastPara="1" vertOverflow="ellipsis" vert="horz" wrap="square" lIns="38100" tIns="19050" rIns="38100" bIns="19050" anchor="ctr" anchorCtr="1">
+                  <a:spAutoFit/>
+                </a:bodyPr>
+                <a:lstStyle/>
+                <a:p>
+                  <a:pPr>
+                    <a:defRPr sz="1300" b="1" i="0" u="none" strike="noStrike" kern="1200" baseline="0">
+                      <a:solidFill>
+                        <a:srgbClr val="002F6C"/>
+                      </a:solidFill>
+                      <a:latin typeface="+mn-lt"/>
+                      <a:ea typeface="+mn-ea"/>
+                      <a:cs typeface="+mn-cs"/>
+                    </a:defRPr>
+                  </a:pPr>
+                  <a:endParaRPr lang="he-IL"/>
+                </a:p>
+              </c:txPr>
+              <c:dLblPos val="outEnd"/>
+              <c:showLegendKey val="0"/>
+              <c:showVal val="1"/>
+              <c:showCatName val="0"/>
+              <c:showSerName val="0"/>
+              <c:showPercent val="0"/>
+              <c:showBubbleSize val="0"/>
+            </c:dLbl>
             <c:spPr>
               <a:noFill/>
               <a:ln>
@@ -2748,12 +2558,9 @@
               <a:lstStyle/>
               <a:p>
                 <a:pPr>
-                  <a:defRPr sz="900" b="0" i="0" u="none" strike="noStrike" kern="1200" baseline="0">
+                  <a:defRPr sz="1200" b="1" i="0" u="none" strike="noStrike" kern="1200" baseline="0">
                     <a:solidFill>
-                      <a:schemeClr val="tx1">
-                        <a:lumMod val="75000"/>
-                        <a:lumOff val="25000"/>
-                      </a:schemeClr>
+                      <a:srgbClr val="5B6B82"/>
                     </a:solidFill>
                     <a:latin typeface="+mn-lt"/>
                     <a:ea typeface="+mn-ea"/>
@@ -2763,6 +2570,7 @@
                 <a:endParaRPr lang="he-IL"/>
               </a:p>
             </c:txPr>
+            <c:dLblPos val="outEnd"/>
             <c:showLegendKey val="0"/>
             <c:showVal val="1"/>
             <c:showCatName val="0"/>
@@ -2770,25 +2578,6 @@
             <c:showPercent val="0"/>
             <c:showBubbleSize val="0"/>
             <c:showLeaderLines val="0"/>
-            <c:extLst>
-              <c:ext xmlns:c15="http://schemas.microsoft.com/office/drawing/2012/chart" uri="{CE6537A1-D6FC-4f65-9D91-7224C49458BB}">
-                <c15:showLeaderLines val="1"/>
-                <c15:leaderLines>
-                  <c:spPr>
-                    <a:ln w="9525" cap="flat" cmpd="sng" algn="ctr">
-                      <a:solidFill>
-                        <a:schemeClr val="tx1">
-                          <a:lumMod val="35000"/>
-                          <a:lumOff val="65000"/>
-                        </a:schemeClr>
-                      </a:solidFill>
-                      <a:round/>
-                    </a:ln>
-                    <a:effectLst/>
-                  </c:spPr>
-                </c15:leaderLines>
-              </c:ext>
-            </c:extLst>
           </c:dLbls>
           <c:cat>
             <c:numRef>
@@ -2852,8 +2641,8 @@
           <c:showPercent val="0"/>
           <c:showBubbleSize val="0"/>
         </c:dLbls>
-        <c:gapWidth val="219"/>
-        <c:overlap val="-27"/>
+        <c:gapWidth val="60"/>
+        <c:overlap val="-10"/>
         <c:axId val="1148800088"/>
         <c:axId val="1148801528"/>
       </c:barChart>
@@ -2872,26 +2661,20 @@
           <a:noFill/>
           <a:ln w="9525" cap="flat" cmpd="sng" algn="ctr">
             <a:solidFill>
-              <a:schemeClr val="tx1">
-                <a:lumMod val="15000"/>
-                <a:lumOff val="85000"/>
-              </a:schemeClr>
+              <a:srgbClr val="D9D9D9"/>
             </a:solidFill>
             <a:round/>
           </a:ln>
           <a:effectLst/>
         </c:spPr>
         <c:txPr>
-          <a:bodyPr rot="-60000000" spcFirstLastPara="1" vertOverflow="ellipsis" vert="horz" wrap="square" anchor="ctr" anchorCtr="1"/>
+          <a:bodyPr rot="0" spcFirstLastPara="1" vertOverflow="ellipsis" vert="horz" wrap="square" anchor="ctr" anchorCtr="1"/>
           <a:lstStyle/>
           <a:p>
             <a:pPr>
-              <a:defRPr sz="900" b="0" i="0" u="none" strike="noStrike" kern="1200" baseline="0">
+              <a:defRPr sz="1100" b="1" i="0" u="none" strike="noStrike" kern="1200" baseline="0">
                 <a:solidFill>
-                  <a:schemeClr val="tx1">
-                    <a:lumMod val="65000"/>
-                    <a:lumOff val="35000"/>
-                  </a:schemeClr>
+                  <a:srgbClr val="5B6B82"/>
                 </a:solidFill>
                 <a:latin typeface="+mn-lt"/>
                 <a:ea typeface="+mn-ea"/>
@@ -2912,6 +2695,8 @@
         <c:axId val="1148801528"/>
         <c:scaling>
           <c:orientation val="minMax"/>
+          <c:max val="33"/>
+          <c:min val="0"/>
         </c:scaling>
         <c:delete val="1"/>
         <c:axPos val="r"/>
@@ -5644,111 +5429,117 @@
 <c:userShapes xmlns:c="http://schemas.openxmlformats.org/drawingml/2006/chart">
   <cdr:relSizeAnchor xmlns:cdr="http://schemas.openxmlformats.org/drawingml/2006/chartDrawing">
     <cdr:from>
-      <cdr:x>0.15717</cdr:x>
-      <cdr:y>0</cdr:y>
+      <cdr:x>0.12</cdr:x>
+      <cdr:y>0.015</cdr:y>
     </cdr:from>
     <cdr:to>
-      <cdr:x>0.87409</cdr:x>
-      <cdr:y>0.15998</cdr:y>
+      <cdr:x>0.885</cdr:x>
+      <cdr:y>0.215</cdr:y>
     </cdr:to>
     <cdr:cxnSp macro="">
       <cdr:nvCxnSpPr>
-        <cdr:cNvPr id="3" name="מחבר חץ ישר 2">
-          <a:extLst xmlns:a="http://schemas.openxmlformats.org/drawingml/2006/main">
-            <a:ext uri="{FF2B5EF4-FFF2-40B4-BE49-F238E27FC236}">
-              <a16:creationId xmlns:a16="http://schemas.microsoft.com/office/drawing/2014/main" id="{1B341FD9-C604-F2A6-41E9-148F103B1205}"/>
-            </a:ext>
-          </a:extLst>
-        </cdr:cNvPr>
+        <cdr:cNvPr id="3" name="חץ מגמת צמיחה"/>
         <cdr:cNvCxnSpPr/>
       </cdr:nvCxnSpPr>
       <cdr:spPr>
-        <a:xfrm xmlns:a="http://schemas.openxmlformats.org/drawingml/2006/main" flipH="1" flipV="1">
-          <a:off x="1118616" y="0"/>
-          <a:ext cx="5102352" cy="569046"/>
+        <a:xfrm xmlns:a="http://schemas.openxmlformats.org/drawingml/2006/main">
+          <a:off x="0" y="0"/>
+          <a:ext cx="1" cy="1"/>
         </a:xfrm>
         <a:prstGeom xmlns:a="http://schemas.openxmlformats.org/drawingml/2006/main" prst="straightConnector1">
           <a:avLst/>
         </a:prstGeom>
-        <a:ln xmlns:a="http://schemas.openxmlformats.org/drawingml/2006/main">
-          <a:tailEnd type="triangle"/>
+        <a:ln xmlns:a="http://schemas.openxmlformats.org/drawingml/2006/main" w="19050" cap="rnd">
+          <a:solidFill>
+            <a:srgbClr val="002F6C"/>
+          </a:solidFill>
+          <a:tailEnd type="triangle" w="med" len="med"/>
         </a:ln>
       </cdr:spPr>
       <cdr:style>
         <a:lnRef xmlns:a="http://schemas.openxmlformats.org/drawingml/2006/main" idx="1">
-          <a:schemeClr val="accent1"/>
+          <a:srgbClr val="002F6C"/>
         </a:lnRef>
         <a:fillRef xmlns:a="http://schemas.openxmlformats.org/drawingml/2006/main" idx="0">
-          <a:schemeClr val="accent1"/>
+          <a:srgbClr val="002F6C"/>
         </a:fillRef>
         <a:effectRef xmlns:a="http://schemas.openxmlformats.org/drawingml/2006/main" idx="0">
-          <a:schemeClr val="accent1"/>
+          <a:srgbClr val="002F6C"/>
         </a:effectRef>
         <a:fontRef xmlns:a="http://schemas.openxmlformats.org/drawingml/2006/main" idx="minor">
-          <a:schemeClr val="tx1"/>
+          <a:srgbClr val="002F6C"/>
         </a:fontRef>
       </cdr:style>
     </cdr:cxnSp>
   </cdr:relSizeAnchor>
   <cdr:relSizeAnchor xmlns:cdr="http://schemas.openxmlformats.org/drawingml/2006/chartDrawing">
     <cdr:from>
-      <cdr:x>0.44454</cdr:x>
-      <cdr:y>0.02464</cdr:y>
+      <cdr:x>0.395</cdr:x>
+      <cdr:y>0.00</cdr:y>
     </cdr:from>
     <cdr:to>
-      <cdr:x>0.62227</cdr:x>
-      <cdr:y>0.13518</cdr:y>
+      <cdr:x>0.605</cdr:x>
+      <cdr:y>0.15</cdr:y>
     </cdr:to>
     <cdr:sp macro="" textlink="">
       <cdr:nvSpPr>
-        <cdr:cNvPr id="6" name="אליפסה 5">
-          <a:extLst xmlns:a="http://schemas.openxmlformats.org/drawingml/2006/main">
-            <a:ext uri="{FF2B5EF4-FFF2-40B4-BE49-F238E27FC236}">
-              <a16:creationId xmlns:a16="http://schemas.microsoft.com/office/drawing/2014/main" id="{46A2963C-5BAA-6215-23F4-1A226E0993AB}"/>
-            </a:ext>
-          </a:extLst>
-        </cdr:cNvPr>
+        <cdr:cNvPr id="6" name="תג צמיחה"/>
         <cdr:cNvSpPr/>
       </cdr:nvSpPr>
       <cdr:spPr>
-        <a:xfrm xmlns:a="http://schemas.openxmlformats.org/drawingml/2006/main" rot="384546">
-          <a:off x="3163824" y="87659"/>
-          <a:ext cx="1264920" cy="393192"/>
+        <a:xfrm xmlns:a="http://schemas.openxmlformats.org/drawingml/2006/main">
+          <a:off x="0" y="0"/>
+          <a:ext cx="1" cy="1"/>
         </a:xfrm>
-        <a:prstGeom xmlns:a="http://schemas.openxmlformats.org/drawingml/2006/main" prst="ellipse">
-          <a:avLst/>
+        <a:prstGeom xmlns:a="http://schemas.openxmlformats.org/drawingml/2006/main" prst="roundRect">
+          <a:avLst>
+            <a:gd name="adj" fmla="val 50000"/>
+          </a:avLst>
         </a:prstGeom>
+        <a:solidFill xmlns:a="http://schemas.openxmlformats.org/drawingml/2006/main">
+          <a:srgbClr val="E0A62B"/>
+        </a:solidFill>
         <a:ln xmlns:a="http://schemas.openxmlformats.org/drawingml/2006/main">
           <a:noFill/>
         </a:ln>
+        <a:effectLst xmlns:a="http://schemas.openxmlformats.org/drawingml/2006/main">
+          <a:outerShdw blurRad="63500" dist="25400" dir="5400000" rotWithShape="0">
+            <a:srgbClr val="002F6C">
+              <a:alpha val="25000"/>
+            </a:srgbClr>
+          </a:outerShdw>
+        </a:effectLst>
       </cdr:spPr>
       <cdr:style>
-        <a:lnRef xmlns:a="http://schemas.openxmlformats.org/drawingml/2006/main" idx="2">
-          <a:schemeClr val="accent1">
-            <a:shade val="15000"/>
-          </a:schemeClr>
+        <a:lnRef xmlns:a="http://schemas.openxmlformats.org/drawingml/2006/main" idx="0">
+          <a:srgbClr val="E0A62B"/>
         </a:lnRef>
-        <a:fillRef xmlns:a="http://schemas.openxmlformats.org/drawingml/2006/main" idx="1">
-          <a:schemeClr val="accent1"/>
+        <a:fillRef xmlns:a="http://schemas.openxmlformats.org/drawingml/2006/main" idx="0">
+          <a:srgbClr val="E0A62B"/>
         </a:fillRef>
         <a:effectRef xmlns:a="http://schemas.openxmlformats.org/drawingml/2006/main" idx="0">
-          <a:schemeClr val="accent1"/>
+          <a:srgbClr val="E0A62B"/>
         </a:effectRef>
         <a:fontRef xmlns:a="http://schemas.openxmlformats.org/drawingml/2006/main" idx="minor">
-          <a:schemeClr val="lt1"/>
+          <a:srgbClr val="FFFFFF"/>
         </a:fontRef>
       </cdr:style>
       <cdr:txBody>
-        <a:bodyPr xmlns:a="http://schemas.openxmlformats.org/drawingml/2006/main" vertOverflow="clip"/>
+        <a:bodyPr xmlns:a="http://schemas.openxmlformats.org/drawingml/2006/main" wrap="square" lIns="45720" tIns="18000" rIns="45720" bIns="18000" anchor="ctr" anchorCtr="1">
+          <a:noAutofit/>
+        </a:bodyPr>
         <a:lstStyle xmlns:a="http://schemas.openxmlformats.org/drawingml/2006/main"/>
         <a:p xmlns:a="http://schemas.openxmlformats.org/drawingml/2006/main">
+          <a:pPr algn="ctr"/>
           <a:r>
-            <a:rPr lang="en-US" sz="1050" kern="1200" dirty="0"/>
-            <a:t>CAGR +5.6</a:t>
-          </a:r>
-          <a:r>
-            <a:rPr lang="he-IL" sz="1050" kern="1200" dirty="0"/>
-            <a:t>ֵ</a:t>
+            <a:rPr lang="he-IL" sz="1500" b="1" kern="1200" dirty="0">
+              <a:solidFill>
+                <a:srgbClr val="002F6C"/>
+              </a:solidFill>
+              <a:latin typeface="+mn-lt"/>
+              <a:cs typeface="+mn-lt"/>
+            </a:rPr>
+            <a:t>24.5%+</a:t>
           </a:r>
         </a:p>
       </cdr:txBody>
@@ -12147,8 +11938,8 @@
           <p:nvPr/>
         </p:nvGraphicFramePr>
         <p:xfrm>
-          <a:off x="1873576" y="1173518"/>
-          <a:ext cx="8207730" cy="4510964"/>
+          <a:off x="1143000" y="1143000"/>
+          <a:ext cx="9906000" cy="4800600"/>
         </p:xfrm>
         <a:graphic>
           <a:graphicData uri="http://schemas.openxmlformats.org/drawingml/2006/chart">

</xml_diff>